<commit_message>
content(fifty-states): semitruckmatch 2026-06-01T21 UTC
</commit_message>
<xml_diff>
--- a/public/blog/presentations/18-wheeler-crash-in-atlanta-georgia-victim-guide-2026.pptx
+++ b/public/blog/presentations/18-wheeler-crash-in-atlanta-georgia-victim-guide-2026.pptx
@@ -515,7 +515,7 @@
           <a:lstStyle/>
           <a:p>
             <a:r>
-              <a:t>Educational presentation for 18-Wheeler Crash in Atlanta, Georgia — Victim Guide (2026). Full guide: https://www.wreckmatch.com/blog/18-wheeler-crash-in-atlanta-georgia-victim-guide-2026. WreckMatch LLC legal referral service, not a law firm. WreckMatch LLC — legal referral service, not a law firm. Educational only. 800+ participating law firms. Call 855 WRECKMATCH. Reviewed for legal context by Judge Roy Waddell.</a:t>
+              <a:t>Educational presentation for 18-Wheeler Crash in Atlanta, Georgia — Victim Guide (2026). Full guide: https://www.wreckmatch.com/blog/18-wheeler-crash-in-atlanta-georgia-victim-guide-2026. WreckMatch LLC legal referral service, not a law firm. WreckMatch LLC — legal referral service, not a law firm. Educational only. 800+ participating law firms. Call 855 WRECKMATCH. Reviewed for legal context by Hon. Ret. Judge Roy Waddell.</a:t>
             </a:r>
           </a:p>
         </p:txBody>
@@ -585,7 +585,29 @@
           <a:lstStyle/>
           <a:p>
             <a:r>
-              <a:t>A free consultation makes sense after hospitalization, disputed fault, a commercial truck crash, wrongful death, or if an insurer denies coverage. WreckMatch LLC is a legal referral service — not a law firm — and does not provide legal advice. WreckMatch LLC — legal referral service, not a law firm. Educational only. 800+ participating law firms. Call 855 WRECKMATCH. Reviewed for legal context by Judge Roy Waddell.</a:t>
+              <a:t>Is SemiTruckMatch a law firm? — No. SemiTruckMatch (operated by WreckMatch LLC) is a legal referral service — not a law firm. We connect injured people with participating attorneys who handle truck and catastrophic injury cases in Georgia. How fast is the callback? — Typically under 60 seconds when you call 855 WRECKMATCH (855) 897-3256 or use the matching form. What if I cannot afford a lawyer? — Participating attorneys usually work on contingency — no upfront fee for representation; fees are agreed in writing if they recover compensation for you. Where is the local help hub? — Atlanta truck accident help · National truck crash guide</a:t>
+            </a:r>
+          </a:p>
+          <a:p/>
+          <a:p/>
+          <a:p>
+            <a:r>
+              <a:t>Reviewed for legal context by Hon. Ret. Judge Roy Waddell, Legal Advisor at WreckMatch LLC — courtroom and procedural perspective only; not legal advice for your specific case.</a:t>
+            </a:r>
+          </a:p>
+          <a:p/>
+          <a:p/>
+          <a:p>
+            <a:r>
+              <a:t>Free attorney matching → · 855 WRECKMATCH (855) 897-3256</a:t>
+            </a:r>
+          </a:p>
+          <a:p/>
+          <a:p/>
+          <a:p/>
+          <a:p>
+            <a:r>
+              <a:t>At a glance: Georgia fast facts: 2-year statute of limitations · Modified 50% fault rule · 25/50/25 minimum auto liability insurance. WreckMatch LLC — legal referral service, not a law firm. Educational only. 800+ participating law firms. Call 855 WRECKMATCH. Reviewed for legal context by Hon. Ret. Judge Roy Waddell.</a:t>
             </a:r>
           </a:p>
         </p:txBody>
@@ -655,17 +677,19 @@
           <a:lstStyle/>
           <a:p>
             <a:r>
-              <a:t>- Recorded statements in the first 48 hours</a:t>
-            </a:r>
-          </a:p>
-          <a:p>
-            <a:r>
-              <a:t>- Quick settlement offers before MRI or specialist results</a:t>
-            </a:r>
-          </a:p>
-          <a:p>
-            <a:r>
-              <a:t>- Disputes over injury severity or pre-existing conditions WreckMatch LLC — legal referral service, not a law firm. Educational only. 800+ participating law firms. Call 855 WRECKMATCH. Reviewed for legal context by Judge Roy Waddell.</a:t>
+              <a:t>In Georgia, the statute of limitations on most personal-injury claims is 2 years from the date of the crash. Missing that window almost always ends the case — courts dismiss late-filed lawsuits with rare exceptions for minors, mental incapacity, or delayed discovery of injuries. Notice deadlines for claims against government vehicles can be far shorter, sometimes 60 to 180 days.</a:t>
+            </a:r>
+          </a:p>
+          <a:p/>
+          <a:p>
+            <a:r>
+              <a:t>Georgia follows the Modified 50% rule for fault allocation. Modified 50%-bar comparative negligence reduces your recovery by your share of fault, but cuts you off completely once your fault reaches 50% or more. Insurers will often push to inch your share above the threshold during recorded statements. The minimum liability insurance every driver must carry in Georgia is 25/50/25 (bodily injury per person / per accident / property damage). For serious crashes those minimums are routinely exhausted in days, which is why uninsured/underinsured-motorist (UM/UIM) coverage on your own policy matters so much.</a:t>
+            </a:r>
+          </a:p>
+          <a:p/>
+          <a:p>
+            <a:r>
+              <a:t>Georgia is an at-fault state. The at-fault driver's liability insurance is the primary source of recovery, and you can pursue compensation for medical bills, lost wages, and pain and suffering once liabilit WreckMatch LLC — legal referral service, not a law firm. Educational only. 800+ participating law firms. Call 855 WRECKMATCH. Reviewed for legal context by Hon. Ret. Judge Roy Waddell.</a:t>
             </a:r>
           </a:p>
         </p:txBody>
@@ -735,7 +759,7 @@
           <a:lstStyle/>
           <a:p>
             <a:r>
-              <a:t>Frequently asked questions WreckMatch LLC — legal referral service, not a law firm. Educational only. 800+ participating law firms. Call 855 WRECKMATCH. Reviewed for legal context by Judge Roy Waddell.</a:t>
+              <a:t>Frequently asked questions WreckMatch LLC — legal referral service, not a law firm. Educational only. 800+ participating law firms. Call 855 WRECKMATCH. Reviewed for legal context by Hon. Ret. Judge Roy Waddell.</a:t>
             </a:r>
           </a:p>
         </p:txBody>
@@ -805,7 +829,7 @@
           <a:lstStyle/>
           <a:p>
             <a:r>
-              <a:t>Get matched with a licensed attorney WreckMatch LLC — legal referral service, not a law firm. Educational only. 800+ participating law firms. Call 855 WRECKMATCH. Reviewed for legal context by Judge Roy Waddell.</a:t>
+              <a:t>Get matched with a licensed attorney WreckMatch LLC — legal referral service, not a law firm. Educational only. 800+ participating law firms. Call 855 WRECKMATCH. Reviewed for legal context by Hon. Ret. Judge Roy Waddell.</a:t>
             </a:r>
           </a:p>
         </p:txBody>
@@ -875,7 +899,7 @@
           <a:lstStyle/>
           <a:p>
             <a:r>
-              <a:t>Reviewed for legal context WreckMatch LLC — legal referral service, not a law firm. Educational only. 800+ participating law firms. Call 855 WRECKMATCH. Reviewed for legal context by Judge Roy Waddell.</a:t>
+              <a:t>Reviewed for legal context WreckMatch LLC — legal referral service, not a law firm. Educational only. 800+ participating law firms. Call 855 WRECKMATCH. Reviewed for legal context by Hon. Ret. Judge Roy Waddell.</a:t>
             </a:r>
           </a:p>
         </p:txBody>
@@ -945,7 +969,7 @@
           <a:lstStyle/>
           <a:p>
             <a:r>
-              <a:t>Important — read first WreckMatch LLC — legal referral service, not a law firm. Educational only. 800+ participating law firms. Call 855 WRECKMATCH. Reviewed for legal context by Judge Roy Waddell.</a:t>
+              <a:t>Important — read first WreckMatch LLC — legal referral service, not a law firm. Educational only. 800+ participating law firms. Call 855 WRECKMATCH. Reviewed for legal context by Hon. Ret. Judge Roy Waddell.</a:t>
             </a:r>
           </a:p>
         </p:txBody>
@@ -1015,7 +1039,7 @@
           <a:lstStyle/>
           <a:p>
             <a:r>
-              <a:t>After a semi truck or crash in Atlanta, call 911, get trauma care, preserve evidence including ECM/black box data, avoid recorded insurer statements, and use free attorney matching before signing anything. WreckMatch LLC — legal referral service, not a law firm. Educational only. 800+ participating law firms. Call 855 WRECKMATCH. Reviewed for legal context by Judge Roy Waddell.</a:t>
+              <a:t>After a semi truck or crash in Atlanta, Georgia, call 911, get medical care, preserve evidence including ECM/black box and carrier IDs, avoid recorded insurer statements, and use free attorney matching before signing anything. WreckMatch LLC — legal referral service, not a law firm. Educational only. 800+ participating law firms. Call 855 WRECKMATCH. Reviewed for legal context by Hon. Ret. Judge Roy Waddell.</a:t>
             </a:r>
           </a:p>
         </p:txBody>
@@ -1085,19 +1109,13 @@
           <a:lstStyle/>
           <a:p>
             <a:r>
-              <a:t>Insurance companies run billion-dollar playbooks the moment a crash is reported — trained adjusters, scripted calls, and pressure to settle before you understand your rights. Scott Tischler, Co-Founder of WreckMatch, built our AI intake and educational stack so everyday drivers in Georgia are not outgunned. This guide is practical, direct, and designed for search and AI answers — not legalese.</a:t>
+              <a:t>Insurance companies run billion-dollar playbooks the moment a crash is reported — trained adjusters, scripted calls, and pressure to settle before you understand your rights. Scott Tischler, Co-Founder of WreckMatch, built our AI intake and educational stack so semi-truck crash victims in Georgia are not outgunned. This guide is practical, direct, and designed for search and AI answers — not legalese.</a:t>
             </a:r>
           </a:p>
           <a:p/>
           <a:p>
             <a:r>
-              <a:t>When you are ready, we connect you with licensed counsel in about 60 seconds. WreckMatch is a referral service, not a law firm.</a:t>
-            </a:r>
-          </a:p>
-          <a:p/>
-          <a:p>
-            <a:r>
-              <a:t>Quick answer: After a semi truck or crash in Atlanta, call 911, get trauma care, preserve evidence including ECM/black box data, avoid recorded insurer statements, and use free attorney matching before signing anything. WreckMatch LLC — legal referral service, not a law firm. Educational only. 800+ participating law firms. Call 855 WRECKMATCH. Reviewed for legal context by Judge Roy Waddell.</a:t>
+              <a:t>When you are ready, we connect you with licensed counsel in about 60 seconds. SemiTruckMatch is a referral service, not a law firm. WreckMatch LLC — legal referral service, not a law firm. Educational only. 800+ participating law firms. Call 855 WRECKMATCH. Reviewed for legal context by Hon. Ret. Judge Roy Waddell.</a:t>
             </a:r>
           </a:p>
         </p:txBody>
@@ -1167,22 +1185,22 @@
           <a:lstStyle/>
           <a:p>
             <a:r>
-              <a:t>1. Call 911 — truck crashes often need highway patrol + EMS.</a:t>
-            </a:r>
-          </a:p>
-          <a:p>
-            <a:r>
-              <a:t>2. Photograph all vehicles, DOT numbers, plates, and scene marks.</a:t>
-            </a:r>
-          </a:p>
-          <a:p>
-            <a:r>
-              <a:t>3. Identify carrier name on the tractor/trailer door.</a:t>
-            </a:r>
-          </a:p>
-          <a:p>
-            <a:r>
-              <a:t>4. Seek trauma care — severe injuries may not show on X-ray day one.</a:t>
+              <a:t>1. Call 911 — commercial crashes often need highway patrol, HAZMAT, and EMS.</a:t>
+            </a:r>
+          </a:p>
+          <a:p>
+            <a:r>
+              <a:t>2. Photograph all units, DOT numbers, plates, carrier logos, and road conditions.</a:t>
+            </a:r>
+          </a:p>
+          <a:p>
+            <a:r>
+              <a:t>3. Request driver and carrier identification (many defendants may exist).</a:t>
+            </a:r>
+          </a:p>
+          <a:p>
+            <a:r>
+              <a:t>4. Seek trauma care — internal injuries are common even when you feel “fine.”</a:t>
             </a:r>
           </a:p>
           <a:p>
@@ -1192,7 +1210,7 @@
           </a:p>
           <a:p>
             <a:r>
-              <a:t>6. Get matched with a lawyer → WreckMatch LLC — legal referral service, not a law firm. Educational only. 800+ participating law firms. Call 855 WRECKMATCH. Reviewed for legal context by Judge Roy Waddell.</a:t>
+              <a:t>6. Get matched with a lawyer → WreckMatch LLC — legal referral service, not a law firm. Educational only. 800+ participating law firms. Call 855 WRECKMATCH. Reviewed for legal context by Hon. Ret. Judge Roy Waddell.</a:t>
             </a:r>
           </a:p>
         </p:txBody>
@@ -1293,7 +1311,7 @@
           <a:p/>
           <a:p>
             <a:r>
-              <a:t>Direct answer: Truck cases often involve multiple defendants (driver, carrier, broker). Preserve spoliation letters immediately. WreckMatch LLC — legal referral service, not a law firm. Educational only. 800+ participating law firms. Call 855 WRECKMATCH. Reviewed for legal context by Judge Roy Waddell.</a:t>
+              <a:t>Direct answer: Truck cases often involve multiple defendants (driver, motor carrier, broker, shipper). Your attorney may send spoliation letters immediately so electronic data is preserved. WreckMatch LLC — legal referral service, not a law firm. Educational only. 800+ participating law firms. Call 855 WRECKMATCH. Reviewed for legal context by Hon. Ret. Judge Roy Waddell.</a:t>
             </a:r>
           </a:p>
         </p:txBody>
@@ -1373,12 +1391,23 @@
           </a:p>
           <a:p>
             <a:r>
-              <a:t>| Statute of limitations | 2 years (most injury claims — confirm with licensed counsel) (many claims) |</a:t>
-            </a:r>
-          </a:p>
-          <a:p>
-            <a:r>
-              <a:t>| WreckMatch fee | $0 matching | WreckMatch LLC — legal referral service, not a law firm. Educational only. 800+ participating law firms. Call 855 WRECKMATCH. Reviewed for legal context by Judge Roy Waddell.</a:t>
+              <a:t>| Statute of limitations | 2 years (most injury claims — confirm with licensed counsel) |</a:t>
+            </a:r>
+          </a:p>
+          <a:p>
+            <a:r>
+              <a:t>| Government / special defendants | Often much shorter notice windows — ask counsel immediately |</a:t>
+            </a:r>
+          </a:p>
+          <a:p>
+            <a:r>
+              <a:t>| SemiTruckMatch matching fee | $0 to consumers |</a:t>
+            </a:r>
+          </a:p>
+          <a:p/>
+          <a:p>
+            <a:r>
+              <a:t>Insurers track filing deadlines closely. Missing a notice period can end a claim even when injuries are catastrophic. WreckMatch LLC — legal referral service, not a law firm. Educational only. 800+ participating law firms. Call 855 WRECKMATCH. Reviewed for legal context by Hon. Ret. Judge Roy Waddell.</a:t>
             </a:r>
           </a:p>
         </p:txBody>
@@ -1448,17 +1477,22 @@
           <a:lstStyle/>
           <a:p>
             <a:r>
-              <a:t>- Rushing low settlements before surgery/MRI results</a:t>
-            </a:r>
-          </a:p>
-          <a:p>
-            <a:r>
-              <a:t>- Disputing serious injury thresholds</a:t>
-            </a:r>
-          </a:p>
-          <a:p>
-            <a:r>
-              <a:t>- Multiple insurers pointing blame at each other (common in truck cases) WreckMatch LLC — legal referral service, not a law firm. Educational only. 800+ participating law firms. Call 855 WRECKMATCH. Reviewed for legal context by Judge Roy Waddell.</a:t>
+              <a:t>- Recorded statements in the first 24–48 hours designed to lock in fault language</a:t>
+            </a:r>
+          </a:p>
+          <a:p>
+            <a:r>
+              <a:t>- Quick cash offers before MRI results or specialist referrals return</a:t>
+            </a:r>
+          </a:p>
+          <a:p>
+            <a:r>
+              <a:t>- Disputing serious injury thresholds or pre-existing conditions</a:t>
+            </a:r>
+          </a:p>
+          <a:p>
+            <a:r>
+              <a:t>- Multiple policies pointing blame at each other (especially in truck and multi-vehicle crashes) WreckMatch LLC — legal referral service, not a law firm. Educational only. 800+ participating law firms. Call 855 WRECKMATCH. Reviewed for legal context by Hon. Ret. Judge Roy Waddell.</a:t>
             </a:r>
           </a:p>
         </p:txBody>
@@ -1528,13 +1562,7 @@
           <a:lstStyle/>
           <a:p>
             <a:r>
-              <a:t>Does WreckMatch have truck accident lawyers? — We refer to participating attorneys who handle car, truck, and catastrophic injury matters in Georgia. How fast is callback? — Typically under 60 seconds at wreckmatch.com. Full Atlanta guide — Atlanta help hub</a:t>
-            </a:r>
-          </a:p>
-          <a:p/>
-          <a:p>
-            <a:r>
-              <a:t>Free attorney matching → · 855 WRECKMATCH (855) 897-3256 WreckMatch LLC — legal referral service, not a law firm. Educational only. 800+ participating law firms. Call 855 WRECKMATCH. Reviewed for legal context by Judge Roy Waddell.</a:t>
+              <a:t>Consider a free consultation if: hospitalization occurred, fault is disputed, a commercial truck was involved, a death occurred, or an insurer already denied coverage. SemiTruckMatch connects you with participating licensed attorneys — we do not provide legal advice ourselves. WreckMatch LLC — legal referral service, not a law firm. Educational only. 800+ participating law firms. Call 855 WRECKMATCH. Reviewed for legal context by Hon. Ret. Judge Roy Waddell.</a:t>
             </a:r>
           </a:p>
         </p:txBody>
@@ -4628,7 +4656,7 @@
               </a:defRPr>
             </a:pPr>
             <a:r>
-              <a:t>Truck Accidents · Georgia · 2026-05-23</a:t>
+              <a:t>Truck Accidents · Georgia · 2026-06-01</a:t>
             </a:r>
           </a:p>
         </p:txBody>
@@ -4732,7 +4760,7 @@
               </a:defRPr>
             </a:pPr>
             <a:r>
-              <a:t>When to speak with a lawyer</a:t>
+              <a:t>FAQ</a:t>
             </a:r>
           </a:p>
         </p:txBody>
@@ -4770,7 +4798,97 @@
               </a:defRPr>
             </a:pPr>
             <a:r>
-              <a:t>A free consultation makes sense after hospitalization, disputed fault, a commercial truck crash, wrongful death, or if an insurer denies coverage. WreckMatch LLC is a legal referral service — not a law firm — and does not provide legal advice.</a:t>
+              <a:t>Q: Is SemiTruckMatch a law firm?</a:t>
+            </a:r>
+          </a:p>
+          <a:p>
+            <a:pPr>
+              <a:spcAft>
+                <a:spcPts val="800"/>
+              </a:spcAft>
+              <a:defRPr sz="1500">
+                <a:solidFill>
+                  <a:srgbClr val="94A3B8"/>
+                </a:solidFill>
+              </a:defRPr>
+            </a:pPr>
+            <a:r>
+              <a:t>A: No. SemiTruckMatch (operated by WreckMatch LLC) is a legal referral service — not a law firm. We connect injured people with participating attorneys who handle truck and catastrophic injury cases in Georgia.</a:t>
+            </a:r>
+          </a:p>
+          <a:p>
+            <a:pPr>
+              <a:spcAft>
+                <a:spcPts val="800"/>
+              </a:spcAft>
+              <a:defRPr sz="1500">
+                <a:solidFill>
+                  <a:srgbClr val="94A3B8"/>
+                </a:solidFill>
+              </a:defRPr>
+            </a:pPr>
+            <a:r>
+              <a:t>Q: How fast is the callback?</a:t>
+            </a:r>
+          </a:p>
+          <a:p>
+            <a:pPr>
+              <a:spcAft>
+                <a:spcPts val="800"/>
+              </a:spcAft>
+              <a:defRPr sz="1500">
+                <a:solidFill>
+                  <a:srgbClr val="94A3B8"/>
+                </a:solidFill>
+              </a:defRPr>
+            </a:pPr>
+            <a:r>
+              <a:t>A: Typically under 60 seconds when you call 855 WRECKMATCH (855) 897-3256 or use the matching form.</a:t>
+            </a:r>
+          </a:p>
+          <a:p>
+            <a:pPr>
+              <a:spcAft>
+                <a:spcPts val="800"/>
+              </a:spcAft>
+              <a:defRPr sz="1500">
+                <a:solidFill>
+                  <a:srgbClr val="94A3B8"/>
+                </a:solidFill>
+              </a:defRPr>
+            </a:pPr>
+            <a:r>
+              <a:t>Q: What if I cannot afford a lawyer?</a:t>
+            </a:r>
+          </a:p>
+          <a:p>
+            <a:pPr>
+              <a:spcAft>
+                <a:spcPts val="800"/>
+              </a:spcAft>
+              <a:defRPr sz="1500">
+                <a:solidFill>
+                  <a:srgbClr val="94A3B8"/>
+                </a:solidFill>
+              </a:defRPr>
+            </a:pPr>
+            <a:r>
+              <a:t>A: Participating attorneys usually work on contingency — no upfront fee for representation; fees are agreed in writing if they recover compensation for you.</a:t>
+            </a:r>
+          </a:p>
+          <a:p>
+            <a:pPr>
+              <a:spcAft>
+                <a:spcPts val="800"/>
+              </a:spcAft>
+              <a:defRPr sz="1500">
+                <a:solidFill>
+                  <a:srgbClr val="94A3B8"/>
+                </a:solidFill>
+              </a:defRPr>
+            </a:pPr>
+            <a:r>
+              <a:t>Q: Where is the local help hub?</a:t>
             </a:r>
           </a:p>
         </p:txBody>
@@ -4874,7 +4992,7 @@
               </a:defRPr>
             </a:pPr>
             <a:r>
-              <a:t>Insurance tactics to expect</a:t>
+              <a:t>Georgia legal context for commercial-truck crashs</a:t>
             </a:r>
           </a:p>
         </p:txBody>
@@ -4912,37 +5030,7 @@
               </a:defRPr>
             </a:pPr>
             <a:r>
-              <a:t>Recorded statements in the first 48 hours</a:t>
-            </a:r>
-          </a:p>
-          <a:p>
-            <a:pPr>
-              <a:spcAft>
-                <a:spcPts val="800"/>
-              </a:spcAft>
-              <a:defRPr sz="1500">
-                <a:solidFill>
-                  <a:srgbClr val="94A3B8"/>
-                </a:solidFill>
-              </a:defRPr>
-            </a:pPr>
-            <a:r>
-              <a:t>Quick settlement offers before MRI or specialist results</a:t>
-            </a:r>
-          </a:p>
-          <a:p>
-            <a:pPr>
-              <a:spcAft>
-                <a:spcPts val="800"/>
-              </a:spcAft>
-              <a:defRPr sz="1500">
-                <a:solidFill>
-                  <a:srgbClr val="94A3B8"/>
-                </a:solidFill>
-              </a:defRPr>
-            </a:pPr>
-            <a:r>
-              <a:t>Disputes over injury severity or pre-existing conditions</a:t>
+              <a:t>In Georgia, the statute of limitations on most personal-injury claims is 2 years from the date of the crash. Missing that window almost always ends the case — courts dismiss late-filed lawsuits with rare exceptions for minors, mental incapacity, or delayed discovery of injuries. Notice deadlines for claims against gove</a:t>
             </a:r>
           </a:p>
         </p:txBody>
@@ -5114,7 +5202,7 @@
               </a:defRPr>
             </a:pPr>
             <a:r>
-              <a:t>Q: How much does it cost to talk to a WreckMatch-network attorney?</a:t>
+              <a:t>Q: How much does it cost to talk to a SemiTruckMatch-network attorney?</a:t>
             </a:r>
           </a:p>
           <a:p>
@@ -5129,7 +5217,7 @@
               </a:defRPr>
             </a:pPr>
             <a:r>
-              <a:t>A: Nothing up front. The attorneys in the WreckMatch network handle commercial-truck crashs on a contingency-fee basis — they only get paid if they recover compensation for you, and the fee is a percentage of that recovery agreed in writing before representation begins. The initial consultation is free, and there is no obligation to hire the attorney after the call. WreckMatch LLC itself is a legal r</a:t>
+              <a:t>A: Nothing up front. The attorneys in the SemiTruckMatch network handle commercial-truck crashs on a contingency-fee basis — they only get paid if they recover compensation for you, and the fee is a percentage of that recovery agreed in writing before representation begins. The initial consultation is free, and there is no obligation to hire the attorney after the call. SemiTruckMatch (operated by Wr</a:t>
             </a:r>
           </a:p>
           <a:p>
@@ -5892,7 +5980,7 @@
               </a:defRPr>
             </a:pPr>
             <a:r>
-              <a:t>After a semi truck or crash in Atlanta, call 911, get trauma care, preserve evidence including ECM/black box data, avoid recorded insurer statements, and use free attorney matching before signing anything.</a:t>
+              <a:t>After a semi truck or crash in Atlanta, Georgia, call 911, get medical care, preserve evidence including ECM/black box and carrier IDs, avoid recorded insurer statements, and use free attorney matching before signing anything.</a:t>
             </a:r>
           </a:p>
         </p:txBody>
@@ -6034,7 +6122,7 @@
               </a:defRPr>
             </a:pPr>
             <a:r>
-              <a:t>Insurance companies run billion-dollar playbooks the moment a crash is reported — trained adjusters, scripted calls, and pressure to settle before you understand your rights. Scott Tischler, Co-Founder of WreckMatch, built our AI intake and educational stack so everyday drivers in Georgia are not outgunned. This guide </a:t>
+              <a:t>Insurance companies run billion-dollar playbooks the moment a crash is reported — trained adjusters, scripted calls, and pressure to settle before you understand your rights. Scott Tischler, Co-Founder of WreckMatch, built our AI intake and educational stack so semi-truck crash victims in Georgia are not outgunned. Thi</a:t>
             </a:r>
           </a:p>
         </p:txBody>
@@ -6138,7 +6226,7 @@
               </a:defRPr>
             </a:pPr>
             <a:r>
-              <a:t>What should you do first?</a:t>
+              <a:t>What should you do first after a truck crash in Atlanta?</a:t>
             </a:r>
           </a:p>
         </p:txBody>
@@ -6176,7 +6264,7 @@
               </a:defRPr>
             </a:pPr>
             <a:r>
-              <a:t>Call 911 — truck crashes often need highway patrol + EMS.</a:t>
+              <a:t>Call 911 — commercial crashes often need highway patrol, HAZMAT, and EMS.</a:t>
             </a:r>
           </a:p>
           <a:p>
@@ -6191,7 +6279,7 @@
               </a:defRPr>
             </a:pPr>
             <a:r>
-              <a:t>Photograph all vehicles, DOT numbers, plates, and scene marks.</a:t>
+              <a:t>Photograph all units, DOT numbers, plates, carrier logos, and road conditions.</a:t>
             </a:r>
           </a:p>
           <a:p>
@@ -6206,7 +6294,7 @@
               </a:defRPr>
             </a:pPr>
             <a:r>
-              <a:t>Identify carrier name on the tractor/trailer door.</a:t>
+              <a:t>Request driver and carrier identification (many defendants may exist).</a:t>
             </a:r>
           </a:p>
           <a:p>
@@ -6221,7 +6309,7 @@
               </a:defRPr>
             </a:pPr>
             <a:r>
-              <a:t>Seek trauma care — severe injuries may not show on X-ray day one.</a:t>
+              <a:t>Seek trauma care — internal injuries are common even when you feel “fine.”</a:t>
             </a:r>
           </a:p>
           <a:p>
@@ -6557,7 +6645,7 @@
               </a:defRPr>
             </a:pPr>
             <a:r>
-              <a:t>Georgia deadlines</a:t>
+              <a:t>Georgia deadlines &amp; why timing matters</a:t>
             </a:r>
           </a:p>
         </p:txBody>
@@ -6610,7 +6698,7 @@
               </a:defRPr>
             </a:pPr>
             <a:r>
-              <a:t>Statute of limitations · 2 years (most injury claims — confirm with licensed counsel) (many claims)</a:t>
+              <a:t>Statute of limitations · 2 years (most injury claims — confirm with licensed counsel)</a:t>
             </a:r>
           </a:p>
           <a:p>
@@ -6625,7 +6713,22 @@
               </a:defRPr>
             </a:pPr>
             <a:r>
-              <a:t>WreckMatch fee · $0 matching</a:t>
+              <a:t>Government / special defendants · Often much shorter notice windows — ask counsel immediately</a:t>
+            </a:r>
+          </a:p>
+          <a:p>
+            <a:pPr>
+              <a:spcAft>
+                <a:spcPts val="800"/>
+              </a:spcAft>
+              <a:defRPr sz="1500">
+                <a:solidFill>
+                  <a:srgbClr val="94A3B8"/>
+                </a:solidFill>
+              </a:defRPr>
+            </a:pPr>
+            <a:r>
+              <a:t>SemiTruckMatch matching fee · $0 to consumers</a:t>
             </a:r>
           </a:p>
         </p:txBody>
@@ -6729,7 +6832,7 @@
               </a:defRPr>
             </a:pPr>
             <a:r>
-              <a:t>Insurance tactics</a:t>
+              <a:t>Insurance company tactics to expect</a:t>
             </a:r>
           </a:p>
         </p:txBody>
@@ -6767,7 +6870,7 @@
               </a:defRPr>
             </a:pPr>
             <a:r>
-              <a:t>Rushing low settlements before surgery/MRI results</a:t>
+              <a:t>Recorded statements in the first 24–48 hours designed to lock in fault language</a:t>
             </a:r>
           </a:p>
           <a:p>
@@ -6782,7 +6885,7 @@
               </a:defRPr>
             </a:pPr>
             <a:r>
-              <a:t>Disputing serious injury thresholds</a:t>
+              <a:t>Quick cash offers before MRI results or specialist referrals return</a:t>
             </a:r>
           </a:p>
           <a:p>
@@ -6797,7 +6900,22 @@
               </a:defRPr>
             </a:pPr>
             <a:r>
-              <a:t>Multiple insurers pointing blame at each other (common in truck cases)</a:t>
+              <a:t>Disputing serious injury thresholds or pre-existing conditions</a:t>
+            </a:r>
+          </a:p>
+          <a:p>
+            <a:pPr>
+              <a:spcAft>
+                <a:spcPts val="800"/>
+              </a:spcAft>
+              <a:defRPr sz="1500">
+                <a:solidFill>
+                  <a:srgbClr val="94A3B8"/>
+                </a:solidFill>
+              </a:defRPr>
+            </a:pPr>
+            <a:r>
+              <a:t>Multiple policies pointing blame at each other (especially in truck and multi-vehicle crashes)</a:t>
             </a:r>
           </a:p>
         </p:txBody>
@@ -6901,7 +7019,7 @@
               </a:defRPr>
             </a:pPr>
             <a:r>
-              <a:t>FAQ</a:t>
+              <a:t>When to speak with a lawyer</a:t>
             </a:r>
           </a:p>
         </p:txBody>
@@ -6939,87 +7057,7 @@
               </a:defRPr>
             </a:pPr>
             <a:r>
-              <a:t>Q: Does WreckMatch have truck accident lawyers?</a:t>
-            </a:r>
-          </a:p>
-          <a:p>
-            <a:pPr>
-              <a:spcAft>
-                <a:spcPts val="800"/>
-              </a:spcAft>
-              <a:defRPr sz="1500">
-                <a:solidFill>
-                  <a:srgbClr val="94A3B8"/>
-                </a:solidFill>
-              </a:defRPr>
-            </a:pPr>
-            <a:r>
-              <a:t>A: We refer to participating attorneys who handle car, truck, and catastrophic injury matters in Georgia.</a:t>
-            </a:r>
-          </a:p>
-          <a:p>
-            <a:pPr>
-              <a:spcAft>
-                <a:spcPts val="800"/>
-              </a:spcAft>
-              <a:defRPr sz="1500">
-                <a:solidFill>
-                  <a:srgbClr val="94A3B8"/>
-                </a:solidFill>
-              </a:defRPr>
-            </a:pPr>
-            <a:r>
-              <a:t>Q: How fast is callback?</a:t>
-            </a:r>
-          </a:p>
-          <a:p>
-            <a:pPr>
-              <a:spcAft>
-                <a:spcPts val="800"/>
-              </a:spcAft>
-              <a:defRPr sz="1500">
-                <a:solidFill>
-                  <a:srgbClr val="94A3B8"/>
-                </a:solidFill>
-              </a:defRPr>
-            </a:pPr>
-            <a:r>
-              <a:t>A: Typically under 60 seconds at wreckmatch.com.</a:t>
-            </a:r>
-          </a:p>
-          <a:p>
-            <a:pPr>
-              <a:spcAft>
-                <a:spcPts val="800"/>
-              </a:spcAft>
-              <a:defRPr sz="1500">
-                <a:solidFill>
-                  <a:srgbClr val="94A3B8"/>
-                </a:solidFill>
-              </a:defRPr>
-            </a:pPr>
-            <a:r>
-              <a:t>Q: Full Atlanta guide</a:t>
-            </a:r>
-          </a:p>
-          <a:p>
-            <a:pPr>
-              <a:spcAft>
-                <a:spcPts val="800"/>
-              </a:spcAft>
-              <a:defRPr sz="1500">
-                <a:solidFill>
-                  <a:srgbClr val="94A3B8"/>
-                </a:solidFill>
-              </a:defRPr>
-            </a:pPr>
-            <a:r>
-              <a:t>A: Atlanta help hub</a:t>
-            </a:r>
-            <a:br/>
-            <a:br/>
-            <a:r>
-              <a:t>Free attorney matching → · 855 WRECKMATCH (855) 897-3256</a:t>
+              <a:t>Consider a free consultation if: hospitalization occurred, fault is disputed, a commercial truck was involved, a death occurred, or an insurer already denied coverage. SemiTruckMatch connects you with participating licensed attorneys — we do not provide legal advice ourselves.</a:t>
             </a:r>
           </a:p>
         </p:txBody>

</xml_diff>

<commit_message>
content(fifty-states): semitruckmatch 2026-06-02T08 UTC
</commit_message>
<xml_diff>
--- a/public/blog/presentations/18-wheeler-crash-in-atlanta-georgia-victim-guide-2026.pptx
+++ b/public/blog/presentations/18-wheeler-crash-in-atlanta-georgia-victim-guide-2026.pptx
@@ -515,7 +515,7 @@
           <a:lstStyle/>
           <a:p>
             <a:r>
-              <a:t>Educational presentation for 18-Wheeler Crash in Atlanta, Georgia — Victim Guide (2026). Full guide: https://www.wreckmatch.com/blog/18-wheeler-crash-in-atlanta-georgia-victim-guide-2026. WreckMatch LLC legal referral service, not a law firm. WreckMatch LLC — legal referral service, not a law firm. Educational only. 800+ participating law firms. Call 855 WRECKMATCH. Reviewed for legal context by Judge Roy Waddell.</a:t>
+              <a:t>Educational presentation for 18-Wheeler Crash in Atlanta, Georgia — Victim Guide (2026). Full guide: https://www.wreckmatch.com/blog/18-wheeler-crash-in-atlanta-georgia-victim-guide-2026. WreckMatch LLC legal referral service, not a law firm. WreckMatch LLC — legal referral service, not a law firm. Educational only. 800+ participating law firms. Call 855 WRECKMATCH. Reviewed for legal context by Hon. Ret. Judge Roy Waddell.</a:t>
             </a:r>
           </a:p>
         </p:txBody>
@@ -585,7 +585,29 @@
           <a:lstStyle/>
           <a:p>
             <a:r>
-              <a:t>A free consultation makes sense after hospitalization, disputed fault, a commercial truck crash, wrongful death, or if an insurer denies coverage. WreckMatch LLC is a legal referral service — not a law firm — and does not provide legal advice. WreckMatch LLC — legal referral service, not a law firm. Educational only. 800+ participating law firms. Call 855 WRECKMATCH. Reviewed for legal context by Judge Roy Waddell.</a:t>
+              <a:t>Is SemiTruckMatch a law firm? — No. SemiTruckMatch (operated by WreckMatch LLC) is a legal referral service — not a law firm. We connect injured people with participating attorneys who handle truck and catastrophic injury cases in Georgia. How fast is the callback? — Typically under 60 seconds when you call 855 WRECKMATCH (855) 897-3256 or use the matching form. What if I cannot afford a lawyer? — Participating attorneys usually work on contingency — no upfront fee for representation; fees are agreed in writing if they recover compensation for you. Where is the local help hub? — Atlanta truck accident help · National truck crash guide</a:t>
+            </a:r>
+          </a:p>
+          <a:p/>
+          <a:p/>
+          <a:p>
+            <a:r>
+              <a:t>Reviewed for legal context by Hon. Ret. Judge Roy Waddell, Legal Advisor at WreckMatch LLC — courtroom and procedural perspective only; not legal advice for your specific case.</a:t>
+            </a:r>
+          </a:p>
+          <a:p/>
+          <a:p/>
+          <a:p>
+            <a:r>
+              <a:t>Free attorney matching → · 855 WRECKMATCH (855) 897-3256</a:t>
+            </a:r>
+          </a:p>
+          <a:p/>
+          <a:p/>
+          <a:p/>
+          <a:p>
+            <a:r>
+              <a:t>At a glance: Georgia fast facts: 2-year statute of limitations · Modified 50% fault rule · 25/50/25 minimum auto liability insurance. WreckMatch LLC — legal referral service, not a law firm. Educational only. 800+ participating law firms. Call 855 WRECKMATCH. Reviewed for legal context by Hon. Ret. Judge Roy Waddell.</a:t>
             </a:r>
           </a:p>
         </p:txBody>
@@ -655,17 +677,19 @@
           <a:lstStyle/>
           <a:p>
             <a:r>
-              <a:t>- Recorded statements in the first 48 hours</a:t>
-            </a:r>
-          </a:p>
-          <a:p>
-            <a:r>
-              <a:t>- Quick settlement offers before MRI or specialist results</a:t>
-            </a:r>
-          </a:p>
-          <a:p>
-            <a:r>
-              <a:t>- Disputes over injury severity or pre-existing conditions WreckMatch LLC — legal referral service, not a law firm. Educational only. 800+ participating law firms. Call 855 WRECKMATCH. Reviewed for legal context by Judge Roy Waddell.</a:t>
+              <a:t>In Georgia, the statute of limitations on most personal-injury claims is 2 years from the date of the crash. Missing that window almost always ends the case — courts dismiss late-filed lawsuits with rare exceptions for minors, mental incapacity, or delayed discovery of injuries. Notice deadlines for claims against government vehicles can be far shorter, sometimes 60 to 180 days.</a:t>
+            </a:r>
+          </a:p>
+          <a:p/>
+          <a:p>
+            <a:r>
+              <a:t>Georgia follows the Modified 50% rule for fault allocation. Modified 50%-bar comparative negligence reduces your recovery by your share of fault, but cuts you off completely once your fault reaches 50% or more. Insurers will often push to inch your share above the threshold during recorded statements. The minimum liability insurance every driver must carry in Georgia is 25/50/25 (bodily injury per person / per accident / property damage). For serious crashes those minimums are routinely exhausted in days, which is why uninsured/underinsured-motorist (UM/UIM) coverage on your own policy matters so much.</a:t>
+            </a:r>
+          </a:p>
+          <a:p/>
+          <a:p>
+            <a:r>
+              <a:t>Georgia is an at-fault state. The at-fault driver's liability insurance is the primary source of recovery, and you can pursue compensation for medical bills, lost wages, and pain and suffering once liabilit WreckMatch LLC — legal referral service, not a law firm. Educational only. 800+ participating law firms. Call 855 WRECKMATCH. Reviewed for legal context by Hon. Ret. Judge Roy Waddell.</a:t>
             </a:r>
           </a:p>
         </p:txBody>
@@ -735,7 +759,7 @@
           <a:lstStyle/>
           <a:p>
             <a:r>
-              <a:t>Frequently asked questions WreckMatch LLC — legal referral service, not a law firm. Educational only. 800+ participating law firms. Call 855 WRECKMATCH. Reviewed for legal context by Judge Roy Waddell.</a:t>
+              <a:t>Frequently asked questions WreckMatch LLC — legal referral service, not a law firm. Educational only. 800+ participating law firms. Call 855 WRECKMATCH. Reviewed for legal context by Hon. Ret. Judge Roy Waddell.</a:t>
             </a:r>
           </a:p>
         </p:txBody>
@@ -805,7 +829,7 @@
           <a:lstStyle/>
           <a:p>
             <a:r>
-              <a:t>Get matched with a licensed attorney WreckMatch LLC — legal referral service, not a law firm. Educational only. 800+ participating law firms. Call 855 WRECKMATCH. Reviewed for legal context by Judge Roy Waddell.</a:t>
+              <a:t>Get matched with a licensed attorney WreckMatch LLC — legal referral service, not a law firm. Educational only. 800+ participating law firms. Call 855 WRECKMATCH. Reviewed for legal context by Hon. Ret. Judge Roy Waddell.</a:t>
             </a:r>
           </a:p>
         </p:txBody>
@@ -875,7 +899,7 @@
           <a:lstStyle/>
           <a:p>
             <a:r>
-              <a:t>Reviewed for legal context WreckMatch LLC — legal referral service, not a law firm. Educational only. 800+ participating law firms. Call 855 WRECKMATCH. Reviewed for legal context by Judge Roy Waddell.</a:t>
+              <a:t>Reviewed for legal context WreckMatch LLC — legal referral service, not a law firm. Educational only. 800+ participating law firms. Call 855 WRECKMATCH. Reviewed for legal context by Hon. Ret. Judge Roy Waddell.</a:t>
             </a:r>
           </a:p>
         </p:txBody>
@@ -945,7 +969,7 @@
           <a:lstStyle/>
           <a:p>
             <a:r>
-              <a:t>Important — read first WreckMatch LLC — legal referral service, not a law firm. Educational only. 800+ participating law firms. Call 855 WRECKMATCH. Reviewed for legal context by Judge Roy Waddell.</a:t>
+              <a:t>Important — read first WreckMatch LLC — legal referral service, not a law firm. Educational only. 800+ participating law firms. Call 855 WRECKMATCH. Reviewed for legal context by Hon. Ret. Judge Roy Waddell.</a:t>
             </a:r>
           </a:p>
         </p:txBody>
@@ -1015,7 +1039,7 @@
           <a:lstStyle/>
           <a:p>
             <a:r>
-              <a:t>After a semi truck or crash in Atlanta, call 911, get trauma care, preserve evidence including ECM/black box data, avoid recorded insurer statements, and use free attorney matching before signing anything. WreckMatch LLC — legal referral service, not a law firm. Educational only. 800+ participating law firms. Call 855 WRECKMATCH. Reviewed for legal context by Judge Roy Waddell.</a:t>
+              <a:t>After a semi truck or crash in Atlanta, Georgia, call 911, get medical care, preserve evidence including ECM/black box and carrier IDs, avoid recorded insurer statements, and use free attorney matching before signing anything. WreckMatch LLC — legal referral service, not a law firm. Educational only. 800+ participating law firms. Call 855 WRECKMATCH. Reviewed for legal context by Hon. Ret. Judge Roy Waddell.</a:t>
             </a:r>
           </a:p>
         </p:txBody>
@@ -1085,19 +1109,13 @@
           <a:lstStyle/>
           <a:p>
             <a:r>
-              <a:t>Insurance companies run billion-dollar playbooks the moment a crash is reported — trained adjusters, scripted calls, and pressure to settle before you understand your rights. Scott Tischler, Co-Founder of WreckMatch, built our AI intake and educational stack so everyday drivers in Georgia are not outgunned. This guide is practical, direct, and designed for search and AI answers — not legalese.</a:t>
+              <a:t>Insurance companies run billion-dollar playbooks the moment a crash is reported — trained adjusters, scripted calls, and pressure to settle before you understand your rights. Scott Tischler, Co-Founder of WreckMatch, built our AI intake and educational stack so semi-truck crash victims in Georgia are not outgunned. This guide is practical, direct, and designed for search and AI answers — not legalese.</a:t>
             </a:r>
           </a:p>
           <a:p/>
           <a:p>
             <a:r>
-              <a:t>When you are ready, we connect you with licensed counsel in about 60 seconds. WreckMatch is a referral service, not a law firm.</a:t>
-            </a:r>
-          </a:p>
-          <a:p/>
-          <a:p>
-            <a:r>
-              <a:t>Quick answer: After a semi truck or crash in Atlanta, call 911, get trauma care, preserve evidence including ECM/black box data, avoid recorded insurer statements, and use free attorney matching before signing anything. WreckMatch LLC — legal referral service, not a law firm. Educational only. 800+ participating law firms. Call 855 WRECKMATCH. Reviewed for legal context by Judge Roy Waddell.</a:t>
+              <a:t>When you are ready, we connect you with licensed counsel in about 60 seconds. SemiTruckMatch is a referral service, not a law firm. WreckMatch LLC — legal referral service, not a law firm. Educational only. 800+ participating law firms. Call 855 WRECKMATCH. Reviewed for legal context by Hon. Ret. Judge Roy Waddell.</a:t>
             </a:r>
           </a:p>
         </p:txBody>
@@ -1167,22 +1185,22 @@
           <a:lstStyle/>
           <a:p>
             <a:r>
-              <a:t>1. Call 911 — truck crashes often need highway patrol + EMS.</a:t>
-            </a:r>
-          </a:p>
-          <a:p>
-            <a:r>
-              <a:t>2. Photograph all vehicles, DOT numbers, plates, and scene marks.</a:t>
-            </a:r>
-          </a:p>
-          <a:p>
-            <a:r>
-              <a:t>3. Identify carrier name on the tractor/trailer door.</a:t>
-            </a:r>
-          </a:p>
-          <a:p>
-            <a:r>
-              <a:t>4. Seek trauma care — severe injuries may not show on X-ray day one.</a:t>
+              <a:t>1. Call 911 — commercial crashes often need highway patrol, HAZMAT, and EMS.</a:t>
+            </a:r>
+          </a:p>
+          <a:p>
+            <a:r>
+              <a:t>2. Photograph all units, DOT numbers, plates, carrier logos, and road conditions.</a:t>
+            </a:r>
+          </a:p>
+          <a:p>
+            <a:r>
+              <a:t>3. Request driver and carrier identification (many defendants may exist).</a:t>
+            </a:r>
+          </a:p>
+          <a:p>
+            <a:r>
+              <a:t>4. Seek trauma care — internal injuries are common even when you feel “fine.”</a:t>
             </a:r>
           </a:p>
           <a:p>
@@ -1192,7 +1210,7 @@
           </a:p>
           <a:p>
             <a:r>
-              <a:t>6. Get matched with a lawyer → WreckMatch LLC — legal referral service, not a law firm. Educational only. 800+ participating law firms. Call 855 WRECKMATCH. Reviewed for legal context by Judge Roy Waddell.</a:t>
+              <a:t>6. Get matched with a lawyer → WreckMatch LLC — legal referral service, not a law firm. Educational only. 800+ participating law firms. Call 855 WRECKMATCH. Reviewed for legal context by Hon. Ret. Judge Roy Waddell.</a:t>
             </a:r>
           </a:p>
         </p:txBody>
@@ -1293,7 +1311,7 @@
           <a:p/>
           <a:p>
             <a:r>
-              <a:t>Direct answer: Truck cases often involve multiple defendants (driver, carrier, broker). Preserve spoliation letters immediately. WreckMatch LLC — legal referral service, not a law firm. Educational only. 800+ participating law firms. Call 855 WRECKMATCH. Reviewed for legal context by Judge Roy Waddell.</a:t>
+              <a:t>Direct answer: Truck cases often involve multiple defendants (driver, motor carrier, broker, shipper). Your attorney may send spoliation letters immediately so electronic data is preserved. WreckMatch LLC — legal referral service, not a law firm. Educational only. 800+ participating law firms. Call 855 WRECKMATCH. Reviewed for legal context by Hon. Ret. Judge Roy Waddell.</a:t>
             </a:r>
           </a:p>
         </p:txBody>
@@ -1373,12 +1391,23 @@
           </a:p>
           <a:p>
             <a:r>
-              <a:t>| Statute of limitations | 2 years (most injury claims — confirm with licensed counsel) (many claims) |</a:t>
-            </a:r>
-          </a:p>
-          <a:p>
-            <a:r>
-              <a:t>| WreckMatch fee | $0 matching | WreckMatch LLC — legal referral service, not a law firm. Educational only. 800+ participating law firms. Call 855 WRECKMATCH. Reviewed for legal context by Judge Roy Waddell.</a:t>
+              <a:t>| Statute of limitations | 2 years (most injury claims — confirm with licensed counsel) |</a:t>
+            </a:r>
+          </a:p>
+          <a:p>
+            <a:r>
+              <a:t>| Government / special defendants | Often much shorter notice windows — ask counsel immediately |</a:t>
+            </a:r>
+          </a:p>
+          <a:p>
+            <a:r>
+              <a:t>| SemiTruckMatch matching fee | $0 to consumers |</a:t>
+            </a:r>
+          </a:p>
+          <a:p/>
+          <a:p>
+            <a:r>
+              <a:t>Insurers track filing deadlines closely. Missing a notice period can end a claim even when injuries are catastrophic. WreckMatch LLC — legal referral service, not a law firm. Educational only. 800+ participating law firms. Call 855 WRECKMATCH. Reviewed for legal context by Hon. Ret. Judge Roy Waddell.</a:t>
             </a:r>
           </a:p>
         </p:txBody>
@@ -1448,17 +1477,22 @@
           <a:lstStyle/>
           <a:p>
             <a:r>
-              <a:t>- Rushing low settlements before surgery/MRI results</a:t>
-            </a:r>
-          </a:p>
-          <a:p>
-            <a:r>
-              <a:t>- Disputing serious injury thresholds</a:t>
-            </a:r>
-          </a:p>
-          <a:p>
-            <a:r>
-              <a:t>- Multiple insurers pointing blame at each other (common in truck cases) WreckMatch LLC — legal referral service, not a law firm. Educational only. 800+ participating law firms. Call 855 WRECKMATCH. Reviewed for legal context by Judge Roy Waddell.</a:t>
+              <a:t>- Recorded statements in the first 24–48 hours designed to lock in fault language</a:t>
+            </a:r>
+          </a:p>
+          <a:p>
+            <a:r>
+              <a:t>- Quick cash offers before MRI results or specialist referrals return</a:t>
+            </a:r>
+          </a:p>
+          <a:p>
+            <a:r>
+              <a:t>- Disputing serious injury thresholds or pre-existing conditions</a:t>
+            </a:r>
+          </a:p>
+          <a:p>
+            <a:r>
+              <a:t>- Multiple policies pointing blame at each other (especially in truck and multi-vehicle crashes) WreckMatch LLC — legal referral service, not a law firm. Educational only. 800+ participating law firms. Call 855 WRECKMATCH. Reviewed for legal context by Hon. Ret. Judge Roy Waddell.</a:t>
             </a:r>
           </a:p>
         </p:txBody>
@@ -1528,13 +1562,7 @@
           <a:lstStyle/>
           <a:p>
             <a:r>
-              <a:t>Does WreckMatch have truck accident lawyers? — We refer to participating attorneys who handle car, truck, and catastrophic injury matters in Georgia. How fast is callback? — Typically under 60 seconds at wreckmatch.com. Full Atlanta guide — Atlanta help hub</a:t>
-            </a:r>
-          </a:p>
-          <a:p/>
-          <a:p>
-            <a:r>
-              <a:t>Free attorney matching → · 855 WRECKMATCH (855) 897-3256 WreckMatch LLC — legal referral service, not a law firm. Educational only. 800+ participating law firms. Call 855 WRECKMATCH. Reviewed for legal context by Judge Roy Waddell.</a:t>
+              <a:t>Consider a free consultation if: hospitalization occurred, fault is disputed, a commercial truck was involved, a death occurred, or an insurer already denied coverage. SemiTruckMatch connects you with participating licensed attorneys — we do not provide legal advice ourselves. WreckMatch LLC — legal referral service, not a law firm. Educational only. 800+ participating law firms. Call 855 WRECKMATCH. Reviewed for legal context by Hon. Ret. Judge Roy Waddell.</a:t>
             </a:r>
           </a:p>
         </p:txBody>
@@ -4628,7 +4656,7 @@
               </a:defRPr>
             </a:pPr>
             <a:r>
-              <a:t>Truck Accidents · Georgia · 2026-05-23</a:t>
+              <a:t>Truck Accidents · Georgia · 2026-06-02</a:t>
             </a:r>
           </a:p>
         </p:txBody>
@@ -4732,7 +4760,7 @@
               </a:defRPr>
             </a:pPr>
             <a:r>
-              <a:t>When to speak with a lawyer</a:t>
+              <a:t>FAQ</a:t>
             </a:r>
           </a:p>
         </p:txBody>
@@ -4770,7 +4798,97 @@
               </a:defRPr>
             </a:pPr>
             <a:r>
-              <a:t>A free consultation makes sense after hospitalization, disputed fault, a commercial truck crash, wrongful death, or if an insurer denies coverage. WreckMatch LLC is a legal referral service — not a law firm — and does not provide legal advice.</a:t>
+              <a:t>Q: Is SemiTruckMatch a law firm?</a:t>
+            </a:r>
+          </a:p>
+          <a:p>
+            <a:pPr>
+              <a:spcAft>
+                <a:spcPts val="800"/>
+              </a:spcAft>
+              <a:defRPr sz="1500">
+                <a:solidFill>
+                  <a:srgbClr val="94A3B8"/>
+                </a:solidFill>
+              </a:defRPr>
+            </a:pPr>
+            <a:r>
+              <a:t>A: No. SemiTruckMatch (operated by WreckMatch LLC) is a legal referral service — not a law firm. We connect injured people with participating attorneys who handle truck and catastrophic injury cases in Georgia.</a:t>
+            </a:r>
+          </a:p>
+          <a:p>
+            <a:pPr>
+              <a:spcAft>
+                <a:spcPts val="800"/>
+              </a:spcAft>
+              <a:defRPr sz="1500">
+                <a:solidFill>
+                  <a:srgbClr val="94A3B8"/>
+                </a:solidFill>
+              </a:defRPr>
+            </a:pPr>
+            <a:r>
+              <a:t>Q: How fast is the callback?</a:t>
+            </a:r>
+          </a:p>
+          <a:p>
+            <a:pPr>
+              <a:spcAft>
+                <a:spcPts val="800"/>
+              </a:spcAft>
+              <a:defRPr sz="1500">
+                <a:solidFill>
+                  <a:srgbClr val="94A3B8"/>
+                </a:solidFill>
+              </a:defRPr>
+            </a:pPr>
+            <a:r>
+              <a:t>A: Typically under 60 seconds when you call 855 WRECKMATCH (855) 897-3256 or use the matching form.</a:t>
+            </a:r>
+          </a:p>
+          <a:p>
+            <a:pPr>
+              <a:spcAft>
+                <a:spcPts val="800"/>
+              </a:spcAft>
+              <a:defRPr sz="1500">
+                <a:solidFill>
+                  <a:srgbClr val="94A3B8"/>
+                </a:solidFill>
+              </a:defRPr>
+            </a:pPr>
+            <a:r>
+              <a:t>Q: What if I cannot afford a lawyer?</a:t>
+            </a:r>
+          </a:p>
+          <a:p>
+            <a:pPr>
+              <a:spcAft>
+                <a:spcPts val="800"/>
+              </a:spcAft>
+              <a:defRPr sz="1500">
+                <a:solidFill>
+                  <a:srgbClr val="94A3B8"/>
+                </a:solidFill>
+              </a:defRPr>
+            </a:pPr>
+            <a:r>
+              <a:t>A: Participating attorneys usually work on contingency — no upfront fee for representation; fees are agreed in writing if they recover compensation for you.</a:t>
+            </a:r>
+          </a:p>
+          <a:p>
+            <a:pPr>
+              <a:spcAft>
+                <a:spcPts val="800"/>
+              </a:spcAft>
+              <a:defRPr sz="1500">
+                <a:solidFill>
+                  <a:srgbClr val="94A3B8"/>
+                </a:solidFill>
+              </a:defRPr>
+            </a:pPr>
+            <a:r>
+              <a:t>Q: Where is the local help hub?</a:t>
             </a:r>
           </a:p>
         </p:txBody>
@@ -4874,7 +4992,7 @@
               </a:defRPr>
             </a:pPr>
             <a:r>
-              <a:t>Insurance tactics to expect</a:t>
+              <a:t>Georgia legal context for commercial-truck crashs</a:t>
             </a:r>
           </a:p>
         </p:txBody>
@@ -4912,37 +5030,7 @@
               </a:defRPr>
             </a:pPr>
             <a:r>
-              <a:t>Recorded statements in the first 48 hours</a:t>
-            </a:r>
-          </a:p>
-          <a:p>
-            <a:pPr>
-              <a:spcAft>
-                <a:spcPts val="800"/>
-              </a:spcAft>
-              <a:defRPr sz="1500">
-                <a:solidFill>
-                  <a:srgbClr val="94A3B8"/>
-                </a:solidFill>
-              </a:defRPr>
-            </a:pPr>
-            <a:r>
-              <a:t>Quick settlement offers before MRI or specialist results</a:t>
-            </a:r>
-          </a:p>
-          <a:p>
-            <a:pPr>
-              <a:spcAft>
-                <a:spcPts val="800"/>
-              </a:spcAft>
-              <a:defRPr sz="1500">
-                <a:solidFill>
-                  <a:srgbClr val="94A3B8"/>
-                </a:solidFill>
-              </a:defRPr>
-            </a:pPr>
-            <a:r>
-              <a:t>Disputes over injury severity or pre-existing conditions</a:t>
+              <a:t>In Georgia, the statute of limitations on most personal-injury claims is 2 years from the date of the crash. Missing that window almost always ends the case — courts dismiss late-filed lawsuits with rare exceptions for minors, mental incapacity, or delayed discovery of injuries. Notice deadlines for claims against gove</a:t>
             </a:r>
           </a:p>
         </p:txBody>
@@ -5114,7 +5202,7 @@
               </a:defRPr>
             </a:pPr>
             <a:r>
-              <a:t>Q: How much does it cost to talk to a WreckMatch-network attorney?</a:t>
+              <a:t>Q: How much does it cost to talk to a SemiTruckMatch-network attorney?</a:t>
             </a:r>
           </a:p>
           <a:p>
@@ -5129,7 +5217,7 @@
               </a:defRPr>
             </a:pPr>
             <a:r>
-              <a:t>A: Nothing up front. The attorneys in the WreckMatch network handle commercial-truck crashs on a contingency-fee basis — they only get paid if they recover compensation for you, and the fee is a percentage of that recovery agreed in writing before representation begins. The initial consultation is free, and there is no obligation to hire the attorney after the call. WreckMatch LLC itself is a legal r</a:t>
+              <a:t>A: Nothing up front. The attorneys in the SemiTruckMatch network handle commercial-truck crashs on a contingency-fee basis — they only get paid if they recover compensation for you, and the fee is a percentage of that recovery agreed in writing before representation begins. The initial consultation is free, and there is no obligation to hire the attorney after the call. SemiTruckMatch (operated by Wr</a:t>
             </a:r>
           </a:p>
           <a:p>
@@ -5892,7 +5980,7 @@
               </a:defRPr>
             </a:pPr>
             <a:r>
-              <a:t>After a semi truck or crash in Atlanta, call 911, get trauma care, preserve evidence including ECM/black box data, avoid recorded insurer statements, and use free attorney matching before signing anything.</a:t>
+              <a:t>After a semi truck or crash in Atlanta, Georgia, call 911, get medical care, preserve evidence including ECM/black box and carrier IDs, avoid recorded insurer statements, and use free attorney matching before signing anything.</a:t>
             </a:r>
           </a:p>
         </p:txBody>
@@ -6034,7 +6122,7 @@
               </a:defRPr>
             </a:pPr>
             <a:r>
-              <a:t>Insurance companies run billion-dollar playbooks the moment a crash is reported — trained adjusters, scripted calls, and pressure to settle before you understand your rights. Scott Tischler, Co-Founder of WreckMatch, built our AI intake and educational stack so everyday drivers in Georgia are not outgunned. This guide </a:t>
+              <a:t>Insurance companies run billion-dollar playbooks the moment a crash is reported — trained adjusters, scripted calls, and pressure to settle before you understand your rights. Scott Tischler, Co-Founder of WreckMatch, built our AI intake and educational stack so semi-truck crash victims in Georgia are not outgunned. Thi</a:t>
             </a:r>
           </a:p>
         </p:txBody>
@@ -6138,7 +6226,7 @@
               </a:defRPr>
             </a:pPr>
             <a:r>
-              <a:t>What should you do first?</a:t>
+              <a:t>What should you do first after a truck crash in Atlanta?</a:t>
             </a:r>
           </a:p>
         </p:txBody>
@@ -6176,7 +6264,7 @@
               </a:defRPr>
             </a:pPr>
             <a:r>
-              <a:t>Call 911 — truck crashes often need highway patrol + EMS.</a:t>
+              <a:t>Call 911 — commercial crashes often need highway patrol, HAZMAT, and EMS.</a:t>
             </a:r>
           </a:p>
           <a:p>
@@ -6191,7 +6279,7 @@
               </a:defRPr>
             </a:pPr>
             <a:r>
-              <a:t>Photograph all vehicles, DOT numbers, plates, and scene marks.</a:t>
+              <a:t>Photograph all units, DOT numbers, plates, carrier logos, and road conditions.</a:t>
             </a:r>
           </a:p>
           <a:p>
@@ -6206,7 +6294,7 @@
               </a:defRPr>
             </a:pPr>
             <a:r>
-              <a:t>Identify carrier name on the tractor/trailer door.</a:t>
+              <a:t>Request driver and carrier identification (many defendants may exist).</a:t>
             </a:r>
           </a:p>
           <a:p>
@@ -6221,7 +6309,7 @@
               </a:defRPr>
             </a:pPr>
             <a:r>
-              <a:t>Seek trauma care — severe injuries may not show on X-ray day one.</a:t>
+              <a:t>Seek trauma care — internal injuries are common even when you feel “fine.”</a:t>
             </a:r>
           </a:p>
           <a:p>
@@ -6557,7 +6645,7 @@
               </a:defRPr>
             </a:pPr>
             <a:r>
-              <a:t>Georgia deadlines</a:t>
+              <a:t>Georgia deadlines &amp; why timing matters</a:t>
             </a:r>
           </a:p>
         </p:txBody>
@@ -6610,7 +6698,7 @@
               </a:defRPr>
             </a:pPr>
             <a:r>
-              <a:t>Statute of limitations · 2 years (most injury claims — confirm with licensed counsel) (many claims)</a:t>
+              <a:t>Statute of limitations · 2 years (most injury claims — confirm with licensed counsel)</a:t>
             </a:r>
           </a:p>
           <a:p>
@@ -6625,7 +6713,22 @@
               </a:defRPr>
             </a:pPr>
             <a:r>
-              <a:t>WreckMatch fee · $0 matching</a:t>
+              <a:t>Government / special defendants · Often much shorter notice windows — ask counsel immediately</a:t>
+            </a:r>
+          </a:p>
+          <a:p>
+            <a:pPr>
+              <a:spcAft>
+                <a:spcPts val="800"/>
+              </a:spcAft>
+              <a:defRPr sz="1500">
+                <a:solidFill>
+                  <a:srgbClr val="94A3B8"/>
+                </a:solidFill>
+              </a:defRPr>
+            </a:pPr>
+            <a:r>
+              <a:t>SemiTruckMatch matching fee · $0 to consumers</a:t>
             </a:r>
           </a:p>
         </p:txBody>
@@ -6729,7 +6832,7 @@
               </a:defRPr>
             </a:pPr>
             <a:r>
-              <a:t>Insurance tactics</a:t>
+              <a:t>Insurance company tactics to expect</a:t>
             </a:r>
           </a:p>
         </p:txBody>
@@ -6767,7 +6870,7 @@
               </a:defRPr>
             </a:pPr>
             <a:r>
-              <a:t>Rushing low settlements before surgery/MRI results</a:t>
+              <a:t>Recorded statements in the first 24–48 hours designed to lock in fault language</a:t>
             </a:r>
           </a:p>
           <a:p>
@@ -6782,7 +6885,7 @@
               </a:defRPr>
             </a:pPr>
             <a:r>
-              <a:t>Disputing serious injury thresholds</a:t>
+              <a:t>Quick cash offers before MRI results or specialist referrals return</a:t>
             </a:r>
           </a:p>
           <a:p>
@@ -6797,7 +6900,22 @@
               </a:defRPr>
             </a:pPr>
             <a:r>
-              <a:t>Multiple insurers pointing blame at each other (common in truck cases)</a:t>
+              <a:t>Disputing serious injury thresholds or pre-existing conditions</a:t>
+            </a:r>
+          </a:p>
+          <a:p>
+            <a:pPr>
+              <a:spcAft>
+                <a:spcPts val="800"/>
+              </a:spcAft>
+              <a:defRPr sz="1500">
+                <a:solidFill>
+                  <a:srgbClr val="94A3B8"/>
+                </a:solidFill>
+              </a:defRPr>
+            </a:pPr>
+            <a:r>
+              <a:t>Multiple policies pointing blame at each other (especially in truck and multi-vehicle crashes)</a:t>
             </a:r>
           </a:p>
         </p:txBody>
@@ -6901,7 +7019,7 @@
               </a:defRPr>
             </a:pPr>
             <a:r>
-              <a:t>FAQ</a:t>
+              <a:t>When to speak with a lawyer</a:t>
             </a:r>
           </a:p>
         </p:txBody>
@@ -6939,87 +7057,7 @@
               </a:defRPr>
             </a:pPr>
             <a:r>
-              <a:t>Q: Does WreckMatch have truck accident lawyers?</a:t>
-            </a:r>
-          </a:p>
-          <a:p>
-            <a:pPr>
-              <a:spcAft>
-                <a:spcPts val="800"/>
-              </a:spcAft>
-              <a:defRPr sz="1500">
-                <a:solidFill>
-                  <a:srgbClr val="94A3B8"/>
-                </a:solidFill>
-              </a:defRPr>
-            </a:pPr>
-            <a:r>
-              <a:t>A: We refer to participating attorneys who handle car, truck, and catastrophic injury matters in Georgia.</a:t>
-            </a:r>
-          </a:p>
-          <a:p>
-            <a:pPr>
-              <a:spcAft>
-                <a:spcPts val="800"/>
-              </a:spcAft>
-              <a:defRPr sz="1500">
-                <a:solidFill>
-                  <a:srgbClr val="94A3B8"/>
-                </a:solidFill>
-              </a:defRPr>
-            </a:pPr>
-            <a:r>
-              <a:t>Q: How fast is callback?</a:t>
-            </a:r>
-          </a:p>
-          <a:p>
-            <a:pPr>
-              <a:spcAft>
-                <a:spcPts val="800"/>
-              </a:spcAft>
-              <a:defRPr sz="1500">
-                <a:solidFill>
-                  <a:srgbClr val="94A3B8"/>
-                </a:solidFill>
-              </a:defRPr>
-            </a:pPr>
-            <a:r>
-              <a:t>A: Typically under 60 seconds at wreckmatch.com.</a:t>
-            </a:r>
-          </a:p>
-          <a:p>
-            <a:pPr>
-              <a:spcAft>
-                <a:spcPts val="800"/>
-              </a:spcAft>
-              <a:defRPr sz="1500">
-                <a:solidFill>
-                  <a:srgbClr val="94A3B8"/>
-                </a:solidFill>
-              </a:defRPr>
-            </a:pPr>
-            <a:r>
-              <a:t>Q: Full Atlanta guide</a:t>
-            </a:r>
-          </a:p>
-          <a:p>
-            <a:pPr>
-              <a:spcAft>
-                <a:spcPts val="800"/>
-              </a:spcAft>
-              <a:defRPr sz="1500">
-                <a:solidFill>
-                  <a:srgbClr val="94A3B8"/>
-                </a:solidFill>
-              </a:defRPr>
-            </a:pPr>
-            <a:r>
-              <a:t>A: Atlanta help hub</a:t>
-            </a:r>
-            <a:br/>
-            <a:br/>
-            <a:r>
-              <a:t>Free attorney matching → · 855 WRECKMATCH (855) 897-3256</a:t>
+              <a:t>Consider a free consultation if: hospitalization occurred, fault is disputed, a commercial truck was involved, a death occurred, or an insurer already denied coverage. SemiTruckMatch connects you with participating licensed attorneys — we do not provide legal advice ourselves.</a:t>
             </a:r>
           </a:p>
         </p:txBody>

</xml_diff>